<commit_message>
Add cleaned presentation reading script for the updated deck and improve presentation visuals with extra charts and robustness summary.
</commit_message>
<xml_diff>
--- a/slides/Education_and_Income_Presentation.pptx
+++ b/slides/Education_and_Income_Presentation.pptx
@@ -5,14 +5,14 @@
     <p:sldMasterId id="2147483648" r:id="rId1"/>
   </p:sldMasterIdLst>
   <p:sldIdLst>
-    <p:sldId id="256" r:id="rId7"/>
-    <p:sldId id="257" r:id="rId8"/>
-    <p:sldId id="258" r:id="rId9"/>
-    <p:sldId id="259" r:id="rId10"/>
-    <p:sldId id="260" r:id="rId11"/>
-    <p:sldId id="261" r:id="rId12"/>
-    <p:sldId id="262" r:id="rId13"/>
-    <p:sldId id="263" r:id="rId14"/>
+    <p:sldId id="256" r:id="rId2"/>
+    <p:sldId id="257" r:id="rId3"/>
+    <p:sldId id="258" r:id="rId4"/>
+    <p:sldId id="259" r:id="rId5"/>
+    <p:sldId id="260" r:id="rId6"/>
+    <p:sldId id="263" r:id="rId7"/>
+    <p:sldId id="261" r:id="rId8"/>
+    <p:sldId id="262" r:id="rId9"/>
   </p:sldIdLst>
   <p:sldSz cx="9144000" cy="6858000" type="screen4x3"/>
   <p:notesSz cx="6858000" cy="9144000"/>
@@ -111,7 +111,52 @@
       </a:defRPr>
     </a:lvl9pPr>
   </p:defaultTextStyle>
+  <p:extLst>
+    <p:ext uri="{EFAFB233-063F-42B5-8137-9DF3F51BA10A}">
+      <p15:sldGuideLst xmlns:p15="http://schemas.microsoft.com/office/powerpoint/2012/main">
+        <p15:guide id="1" orient="horz" pos="2160">
+          <p15:clr>
+            <a:srgbClr val="A4A3A4"/>
+          </p15:clr>
+        </p15:guide>
+        <p15:guide id="2" pos="2880">
+          <p15:clr>
+            <a:srgbClr val="A4A3A4"/>
+          </p15:clr>
+        </p15:guide>
+      </p15:sldGuideLst>
+    </p:ext>
+  </p:extLst>
 </p:presentation>
+</file>
+
+<file path=ppt/changesInfos/changesInfo1.xml><?xml version="1.0" encoding="utf-8"?>
+<pc:chgInfo xmlns:a="http://schemas.openxmlformats.org/drawingml/2006/main" xmlns:r="http://schemas.openxmlformats.org/officeDocument/2006/relationships" xmlns:ac="http://schemas.microsoft.com/office/drawing/2013/main/command" xmlns:pc="http://schemas.microsoft.com/office/powerpoint/2013/main/command">
+  <pc:docChgLst>
+    <pc:chgData name="George Lewis" userId="09c2c9ccd486a171" providerId="LiveId" clId="{C7FFF7A7-2C27-497E-8D5C-F9765F6B16A5}"/>
+    <pc:docChg chg="modSld sldOrd">
+      <pc:chgData name="George Lewis" userId="09c2c9ccd486a171" providerId="LiveId" clId="{C7FFF7A7-2C27-497E-8D5C-F9765F6B16A5}" dt="2026-05-25T06:17:59.648" v="2"/>
+      <pc:docMkLst>
+        <pc:docMk/>
+      </pc:docMkLst>
+      <pc:sldChg chg="modSp mod ord">
+        <pc:chgData name="George Lewis" userId="09c2c9ccd486a171" providerId="LiveId" clId="{C7FFF7A7-2C27-497E-8D5C-F9765F6B16A5}" dt="2026-05-25T06:17:59.648" v="2"/>
+        <pc:sldMkLst>
+          <pc:docMk/>
+          <pc:sldMk cId="0" sldId="263"/>
+        </pc:sldMkLst>
+        <pc:picChg chg="mod">
+          <ac:chgData name="George Lewis" userId="09c2c9ccd486a171" providerId="LiveId" clId="{C7FFF7A7-2C27-497E-8D5C-F9765F6B16A5}" dt="2026-05-25T05:50:12.789" v="0" actId="1076"/>
+          <ac:picMkLst>
+            <pc:docMk/>
+            <pc:sldMk cId="0" sldId="263"/>
+            <ac:picMk id="4" creationId="{00000000-0000-0000-0000-000000000000}"/>
+          </ac:picMkLst>
+        </pc:picChg>
+      </pc:sldChg>
+    </pc:docChg>
+  </pc:docChgLst>
+</pc:chgInfo>
 </file>
 
 <file path=ppt/slideLayouts/slideLayout1.xml><?xml version="1.0" encoding="utf-8"?>
@@ -152,10 +197,9 @@
           <a:lstStyle/>
           <a:p>
             <a:r>
-              <a:rPr lang="en-US" smtClean="0"/>
+              <a:rPr lang="en-US"/>
               <a:t>Click to edit Master title style</a:t>
             </a:r>
-            <a:endParaRPr lang="en-US"/>
           </a:p>
         </p:txBody>
       </p:sp>
@@ -271,10 +315,9 @@
           </a:lstStyle>
           <a:p>
             <a:r>
-              <a:rPr lang="en-US" smtClean="0"/>
+              <a:rPr lang="en-US"/>
               <a:t>Click to edit Master subtitle style</a:t>
             </a:r>
-            <a:endParaRPr lang="en-US"/>
           </a:p>
         </p:txBody>
       </p:sp>
@@ -295,7 +338,7 @@
           <a:p>
             <a:fld id="{5BCAD085-E8A6-8845-BD4E-CB4CCA059FC4}" type="datetimeFigureOut">
               <a:rPr lang="en-US" smtClean="0"/>
-              <a:t>1/27/13</a:t>
+              <a:t>5/25/2026</a:t>
             </a:fld>
             <a:endParaRPr lang="en-US"/>
           </a:p>
@@ -389,10 +432,9 @@
           <a:lstStyle/>
           <a:p>
             <a:r>
-              <a:rPr lang="en-US" smtClean="0"/>
+              <a:rPr lang="en-US"/>
               <a:t>Click to edit Master title style</a:t>
             </a:r>
-            <a:endParaRPr lang="en-US"/>
           </a:p>
         </p:txBody>
       </p:sp>
@@ -413,38 +455,37 @@
           <a:p>
             <a:pPr lvl="0"/>
             <a:r>
-              <a:rPr lang="en-US" smtClean="0"/>
+              <a:rPr lang="en-US"/>
               <a:t>Click to edit Master text styles</a:t>
             </a:r>
           </a:p>
           <a:p>
             <a:pPr lvl="1"/>
             <a:r>
-              <a:rPr lang="en-US" smtClean="0"/>
+              <a:rPr lang="en-US"/>
               <a:t>Second level</a:t>
             </a:r>
           </a:p>
           <a:p>
             <a:pPr lvl="2"/>
             <a:r>
-              <a:rPr lang="en-US" smtClean="0"/>
+              <a:rPr lang="en-US"/>
               <a:t>Third level</a:t>
             </a:r>
           </a:p>
           <a:p>
             <a:pPr lvl="3"/>
             <a:r>
-              <a:rPr lang="en-US" smtClean="0"/>
+              <a:rPr lang="en-US"/>
               <a:t>Fourth level</a:t>
             </a:r>
           </a:p>
           <a:p>
             <a:pPr lvl="4"/>
             <a:r>
-              <a:rPr lang="en-US" smtClean="0"/>
+              <a:rPr lang="en-US"/>
               <a:t>Fifth level</a:t>
             </a:r>
-            <a:endParaRPr lang="en-US"/>
           </a:p>
         </p:txBody>
       </p:sp>
@@ -465,7 +506,7 @@
           <a:p>
             <a:fld id="{5BCAD085-E8A6-8845-BD4E-CB4CCA059FC4}" type="datetimeFigureOut">
               <a:rPr lang="en-US" smtClean="0"/>
-              <a:t>1/27/13</a:t>
+              <a:t>5/25/2026</a:t>
             </a:fld>
             <a:endParaRPr lang="en-US"/>
           </a:p>
@@ -564,10 +605,9 @@
           <a:lstStyle/>
           <a:p>
             <a:r>
-              <a:rPr lang="en-US" smtClean="0"/>
+              <a:rPr lang="en-US"/>
               <a:t>Click to edit Master title style</a:t>
             </a:r>
-            <a:endParaRPr lang="en-US"/>
           </a:p>
         </p:txBody>
       </p:sp>
@@ -593,38 +633,37 @@
           <a:p>
             <a:pPr lvl="0"/>
             <a:r>
-              <a:rPr lang="en-US" smtClean="0"/>
+              <a:rPr lang="en-US"/>
               <a:t>Click to edit Master text styles</a:t>
             </a:r>
           </a:p>
           <a:p>
             <a:pPr lvl="1"/>
             <a:r>
-              <a:rPr lang="en-US" smtClean="0"/>
+              <a:rPr lang="en-US"/>
               <a:t>Second level</a:t>
             </a:r>
           </a:p>
           <a:p>
             <a:pPr lvl="2"/>
             <a:r>
-              <a:rPr lang="en-US" smtClean="0"/>
+              <a:rPr lang="en-US"/>
               <a:t>Third level</a:t>
             </a:r>
           </a:p>
           <a:p>
             <a:pPr lvl="3"/>
             <a:r>
-              <a:rPr lang="en-US" smtClean="0"/>
+              <a:rPr lang="en-US"/>
               <a:t>Fourth level</a:t>
             </a:r>
           </a:p>
           <a:p>
             <a:pPr lvl="4"/>
             <a:r>
-              <a:rPr lang="en-US" smtClean="0"/>
+              <a:rPr lang="en-US"/>
               <a:t>Fifth level</a:t>
             </a:r>
-            <a:endParaRPr lang="en-US"/>
           </a:p>
         </p:txBody>
       </p:sp>
@@ -645,7 +684,7 @@
           <a:p>
             <a:fld id="{5BCAD085-E8A6-8845-BD4E-CB4CCA059FC4}" type="datetimeFigureOut">
               <a:rPr lang="en-US" smtClean="0"/>
-              <a:t>1/27/13</a:t>
+              <a:t>5/25/2026</a:t>
             </a:fld>
             <a:endParaRPr lang="en-US"/>
           </a:p>
@@ -739,10 +778,9 @@
           <a:lstStyle/>
           <a:p>
             <a:r>
-              <a:rPr lang="en-US" smtClean="0"/>
+              <a:rPr lang="en-US"/>
               <a:t>Click to edit Master title style</a:t>
             </a:r>
-            <a:endParaRPr lang="en-US"/>
           </a:p>
         </p:txBody>
       </p:sp>
@@ -763,38 +801,37 @@
           <a:p>
             <a:pPr lvl="0"/>
             <a:r>
-              <a:rPr lang="en-US" smtClean="0"/>
+              <a:rPr lang="en-US"/>
               <a:t>Click to edit Master text styles</a:t>
             </a:r>
           </a:p>
           <a:p>
             <a:pPr lvl="1"/>
             <a:r>
-              <a:rPr lang="en-US" smtClean="0"/>
+              <a:rPr lang="en-US"/>
               <a:t>Second level</a:t>
             </a:r>
           </a:p>
           <a:p>
             <a:pPr lvl="2"/>
             <a:r>
-              <a:rPr lang="en-US" smtClean="0"/>
+              <a:rPr lang="en-US"/>
               <a:t>Third level</a:t>
             </a:r>
           </a:p>
           <a:p>
             <a:pPr lvl="3"/>
             <a:r>
-              <a:rPr lang="en-US" smtClean="0"/>
+              <a:rPr lang="en-US"/>
               <a:t>Fourth level</a:t>
             </a:r>
           </a:p>
           <a:p>
             <a:pPr lvl="4"/>
             <a:r>
-              <a:rPr lang="en-US" smtClean="0"/>
+              <a:rPr lang="en-US"/>
               <a:t>Fifth level</a:t>
             </a:r>
-            <a:endParaRPr lang="en-US"/>
           </a:p>
         </p:txBody>
       </p:sp>
@@ -815,7 +852,7 @@
           <a:p>
             <a:fld id="{5BCAD085-E8A6-8845-BD4E-CB4CCA059FC4}" type="datetimeFigureOut">
               <a:rPr lang="en-US" smtClean="0"/>
-              <a:t>1/27/13</a:t>
+              <a:t>5/25/2026</a:t>
             </a:fld>
             <a:endParaRPr lang="en-US"/>
           </a:p>
@@ -918,10 +955,9 @@
           </a:lstStyle>
           <a:p>
             <a:r>
-              <a:rPr lang="en-US" smtClean="0"/>
+              <a:rPr lang="en-US"/>
               <a:t>Click to edit Master title style</a:t>
             </a:r>
-            <a:endParaRPr lang="en-US"/>
           </a:p>
         </p:txBody>
       </p:sp>
@@ -1038,7 +1074,7 @@
           <a:p>
             <a:pPr lvl="0"/>
             <a:r>
-              <a:rPr lang="en-US" smtClean="0"/>
+              <a:rPr lang="en-US"/>
               <a:t>Click to edit Master text styles</a:t>
             </a:r>
           </a:p>
@@ -1061,7 +1097,7 @@
           <a:p>
             <a:fld id="{5BCAD085-E8A6-8845-BD4E-CB4CCA059FC4}" type="datetimeFigureOut">
               <a:rPr lang="en-US" smtClean="0"/>
-              <a:t>1/27/13</a:t>
+              <a:t>5/25/2026</a:t>
             </a:fld>
             <a:endParaRPr lang="en-US"/>
           </a:p>
@@ -1155,10 +1191,9 @@
           <a:lstStyle/>
           <a:p>
             <a:r>
-              <a:rPr lang="en-US" smtClean="0"/>
+              <a:rPr lang="en-US"/>
               <a:t>Click to edit Master title style</a:t>
             </a:r>
-            <a:endParaRPr lang="en-US"/>
           </a:p>
         </p:txBody>
       </p:sp>
@@ -1212,38 +1247,37 @@
           <a:p>
             <a:pPr lvl="0"/>
             <a:r>
-              <a:rPr lang="en-US" smtClean="0"/>
+              <a:rPr lang="en-US"/>
               <a:t>Click to edit Master text styles</a:t>
             </a:r>
           </a:p>
           <a:p>
             <a:pPr lvl="1"/>
             <a:r>
-              <a:rPr lang="en-US" smtClean="0"/>
+              <a:rPr lang="en-US"/>
               <a:t>Second level</a:t>
             </a:r>
           </a:p>
           <a:p>
             <a:pPr lvl="2"/>
             <a:r>
-              <a:rPr lang="en-US" smtClean="0"/>
+              <a:rPr lang="en-US"/>
               <a:t>Third level</a:t>
             </a:r>
           </a:p>
           <a:p>
             <a:pPr lvl="3"/>
             <a:r>
-              <a:rPr lang="en-US" smtClean="0"/>
+              <a:rPr lang="en-US"/>
               <a:t>Fourth level</a:t>
             </a:r>
           </a:p>
           <a:p>
             <a:pPr lvl="4"/>
             <a:r>
-              <a:rPr lang="en-US" smtClean="0"/>
+              <a:rPr lang="en-US"/>
               <a:t>Fifth level</a:t>
             </a:r>
-            <a:endParaRPr lang="en-US"/>
           </a:p>
         </p:txBody>
       </p:sp>
@@ -1297,38 +1331,37 @@
           <a:p>
             <a:pPr lvl="0"/>
             <a:r>
-              <a:rPr lang="en-US" smtClean="0"/>
+              <a:rPr lang="en-US"/>
               <a:t>Click to edit Master text styles</a:t>
             </a:r>
           </a:p>
           <a:p>
             <a:pPr lvl="1"/>
             <a:r>
-              <a:rPr lang="en-US" smtClean="0"/>
+              <a:rPr lang="en-US"/>
               <a:t>Second level</a:t>
             </a:r>
           </a:p>
           <a:p>
             <a:pPr lvl="2"/>
             <a:r>
-              <a:rPr lang="en-US" smtClean="0"/>
+              <a:rPr lang="en-US"/>
               <a:t>Third level</a:t>
             </a:r>
           </a:p>
           <a:p>
             <a:pPr lvl="3"/>
             <a:r>
-              <a:rPr lang="en-US" smtClean="0"/>
+              <a:rPr lang="en-US"/>
               <a:t>Fourth level</a:t>
             </a:r>
           </a:p>
           <a:p>
             <a:pPr lvl="4"/>
             <a:r>
-              <a:rPr lang="en-US" smtClean="0"/>
+              <a:rPr lang="en-US"/>
               <a:t>Fifth level</a:t>
             </a:r>
-            <a:endParaRPr lang="en-US"/>
           </a:p>
         </p:txBody>
       </p:sp>
@@ -1349,7 +1382,7 @@
           <a:p>
             <a:fld id="{5BCAD085-E8A6-8845-BD4E-CB4CCA059FC4}" type="datetimeFigureOut">
               <a:rPr lang="en-US" smtClean="0"/>
-              <a:t>1/27/13</a:t>
+              <a:t>5/25/2026</a:t>
             </a:fld>
             <a:endParaRPr lang="en-US"/>
           </a:p>
@@ -1447,10 +1480,9 @@
           </a:lstStyle>
           <a:p>
             <a:r>
-              <a:rPr lang="en-US" smtClean="0"/>
+              <a:rPr lang="en-US"/>
               <a:t>Click to edit Master title style</a:t>
             </a:r>
-            <a:endParaRPr lang="en-US"/>
           </a:p>
         </p:txBody>
       </p:sp>
@@ -1513,7 +1545,7 @@
           <a:p>
             <a:pPr lvl="0"/>
             <a:r>
-              <a:rPr lang="en-US" smtClean="0"/>
+              <a:rPr lang="en-US"/>
               <a:t>Click to edit Master text styles</a:t>
             </a:r>
           </a:p>
@@ -1569,38 +1601,37 @@
           <a:p>
             <a:pPr lvl="0"/>
             <a:r>
-              <a:rPr lang="en-US" smtClean="0"/>
+              <a:rPr lang="en-US"/>
               <a:t>Click to edit Master text styles</a:t>
             </a:r>
           </a:p>
           <a:p>
             <a:pPr lvl="1"/>
             <a:r>
-              <a:rPr lang="en-US" smtClean="0"/>
+              <a:rPr lang="en-US"/>
               <a:t>Second level</a:t>
             </a:r>
           </a:p>
           <a:p>
             <a:pPr lvl="2"/>
             <a:r>
-              <a:rPr lang="en-US" smtClean="0"/>
+              <a:rPr lang="en-US"/>
               <a:t>Third level</a:t>
             </a:r>
           </a:p>
           <a:p>
             <a:pPr lvl="3"/>
             <a:r>
-              <a:rPr lang="en-US" smtClean="0"/>
+              <a:rPr lang="en-US"/>
               <a:t>Fourth level</a:t>
             </a:r>
           </a:p>
           <a:p>
             <a:pPr lvl="4"/>
             <a:r>
-              <a:rPr lang="en-US" smtClean="0"/>
+              <a:rPr lang="en-US"/>
               <a:t>Fifth level</a:t>
             </a:r>
-            <a:endParaRPr lang="en-US"/>
           </a:p>
         </p:txBody>
       </p:sp>
@@ -1663,7 +1694,7 @@
           <a:p>
             <a:pPr lvl="0"/>
             <a:r>
-              <a:rPr lang="en-US" smtClean="0"/>
+              <a:rPr lang="en-US"/>
               <a:t>Click to edit Master text styles</a:t>
             </a:r>
           </a:p>
@@ -1719,38 +1750,37 @@
           <a:p>
             <a:pPr lvl="0"/>
             <a:r>
-              <a:rPr lang="en-US" smtClean="0"/>
+              <a:rPr lang="en-US"/>
               <a:t>Click to edit Master text styles</a:t>
             </a:r>
           </a:p>
           <a:p>
             <a:pPr lvl="1"/>
             <a:r>
-              <a:rPr lang="en-US" smtClean="0"/>
+              <a:rPr lang="en-US"/>
               <a:t>Second level</a:t>
             </a:r>
           </a:p>
           <a:p>
             <a:pPr lvl="2"/>
             <a:r>
-              <a:rPr lang="en-US" smtClean="0"/>
+              <a:rPr lang="en-US"/>
               <a:t>Third level</a:t>
             </a:r>
           </a:p>
           <a:p>
             <a:pPr lvl="3"/>
             <a:r>
-              <a:rPr lang="en-US" smtClean="0"/>
+              <a:rPr lang="en-US"/>
               <a:t>Fourth level</a:t>
             </a:r>
           </a:p>
           <a:p>
             <a:pPr lvl="4"/>
             <a:r>
-              <a:rPr lang="en-US" smtClean="0"/>
+              <a:rPr lang="en-US"/>
               <a:t>Fifth level</a:t>
             </a:r>
-            <a:endParaRPr lang="en-US"/>
           </a:p>
         </p:txBody>
       </p:sp>
@@ -1771,7 +1801,7 @@
           <a:p>
             <a:fld id="{5BCAD085-E8A6-8845-BD4E-CB4CCA059FC4}" type="datetimeFigureOut">
               <a:rPr lang="en-US" smtClean="0"/>
-              <a:t>1/27/13</a:t>
+              <a:t>5/25/2026</a:t>
             </a:fld>
             <a:endParaRPr lang="en-US"/>
           </a:p>
@@ -1865,10 +1895,9 @@
           <a:lstStyle/>
           <a:p>
             <a:r>
-              <a:rPr lang="en-US" smtClean="0"/>
+              <a:rPr lang="en-US"/>
               <a:t>Click to edit Master title style</a:t>
             </a:r>
-            <a:endParaRPr lang="en-US"/>
           </a:p>
         </p:txBody>
       </p:sp>
@@ -1889,7 +1918,7 @@
           <a:p>
             <a:fld id="{5BCAD085-E8A6-8845-BD4E-CB4CCA059FC4}" type="datetimeFigureOut">
               <a:rPr lang="en-US" smtClean="0"/>
-              <a:t>1/27/13</a:t>
+              <a:t>5/25/2026</a:t>
             </a:fld>
             <a:endParaRPr lang="en-US"/>
           </a:p>
@@ -1984,7 +2013,7 @@
           <a:p>
             <a:fld id="{5BCAD085-E8A6-8845-BD4E-CB4CCA059FC4}" type="datetimeFigureOut">
               <a:rPr lang="en-US" smtClean="0"/>
-              <a:t>1/27/13</a:t>
+              <a:t>5/25/2026</a:t>
             </a:fld>
             <a:endParaRPr lang="en-US"/>
           </a:p>
@@ -2087,10 +2116,9 @@
           </a:lstStyle>
           <a:p>
             <a:r>
-              <a:rPr lang="en-US" smtClean="0"/>
+              <a:rPr lang="en-US"/>
               <a:t>Click to edit Master title style</a:t>
             </a:r>
-            <a:endParaRPr lang="en-US"/>
           </a:p>
         </p:txBody>
       </p:sp>
@@ -2144,38 +2172,37 @@
           <a:p>
             <a:pPr lvl="0"/>
             <a:r>
-              <a:rPr lang="en-US" smtClean="0"/>
+              <a:rPr lang="en-US"/>
               <a:t>Click to edit Master text styles</a:t>
             </a:r>
           </a:p>
           <a:p>
             <a:pPr lvl="1"/>
             <a:r>
-              <a:rPr lang="en-US" smtClean="0"/>
+              <a:rPr lang="en-US"/>
               <a:t>Second level</a:t>
             </a:r>
           </a:p>
           <a:p>
             <a:pPr lvl="2"/>
             <a:r>
-              <a:rPr lang="en-US" smtClean="0"/>
+              <a:rPr lang="en-US"/>
               <a:t>Third level</a:t>
             </a:r>
           </a:p>
           <a:p>
             <a:pPr lvl="3"/>
             <a:r>
-              <a:rPr lang="en-US" smtClean="0"/>
+              <a:rPr lang="en-US"/>
               <a:t>Fourth level</a:t>
             </a:r>
           </a:p>
           <a:p>
             <a:pPr lvl="4"/>
             <a:r>
-              <a:rPr lang="en-US" smtClean="0"/>
+              <a:rPr lang="en-US"/>
               <a:t>Fifth level</a:t>
             </a:r>
-            <a:endParaRPr lang="en-US"/>
           </a:p>
         </p:txBody>
       </p:sp>
@@ -2238,7 +2265,7 @@
           <a:p>
             <a:pPr lvl="0"/>
             <a:r>
-              <a:rPr lang="en-US" smtClean="0"/>
+              <a:rPr lang="en-US"/>
               <a:t>Click to edit Master text styles</a:t>
             </a:r>
           </a:p>
@@ -2261,7 +2288,7 @@
           <a:p>
             <a:fld id="{5BCAD085-E8A6-8845-BD4E-CB4CCA059FC4}" type="datetimeFigureOut">
               <a:rPr lang="en-US" smtClean="0"/>
-              <a:t>1/27/13</a:t>
+              <a:t>5/25/2026</a:t>
             </a:fld>
             <a:endParaRPr lang="en-US"/>
           </a:p>
@@ -2364,10 +2391,9 @@
           </a:lstStyle>
           <a:p>
             <a:r>
-              <a:rPr lang="en-US" smtClean="0"/>
+              <a:rPr lang="en-US"/>
               <a:t>Click to edit Master title style</a:t>
             </a:r>
-            <a:endParaRPr lang="en-US"/>
           </a:p>
         </p:txBody>
       </p:sp>
@@ -2491,7 +2517,7 @@
           <a:p>
             <a:pPr lvl="0"/>
             <a:r>
-              <a:rPr lang="en-US" smtClean="0"/>
+              <a:rPr lang="en-US"/>
               <a:t>Click to edit Master text styles</a:t>
             </a:r>
           </a:p>
@@ -2514,7 +2540,7 @@
           <a:p>
             <a:fld id="{5BCAD085-E8A6-8845-BD4E-CB4CCA059FC4}" type="datetimeFigureOut">
               <a:rPr lang="en-US" smtClean="0"/>
-              <a:t>1/27/13</a:t>
+              <a:t>5/25/2026</a:t>
             </a:fld>
             <a:endParaRPr lang="en-US"/>
           </a:p>
@@ -2623,10 +2649,9 @@
           <a:lstStyle/>
           <a:p>
             <a:r>
-              <a:rPr lang="en-US" smtClean="0"/>
+              <a:rPr lang="en-US"/>
               <a:t>Click to edit Master title style</a:t>
             </a:r>
-            <a:endParaRPr lang="en-US"/>
           </a:p>
         </p:txBody>
       </p:sp>
@@ -2657,38 +2682,37 @@
           <a:p>
             <a:pPr lvl="0"/>
             <a:r>
-              <a:rPr lang="en-US" smtClean="0"/>
+              <a:rPr lang="en-US"/>
               <a:t>Click to edit Master text styles</a:t>
             </a:r>
           </a:p>
           <a:p>
             <a:pPr lvl="1"/>
             <a:r>
-              <a:rPr lang="en-US" smtClean="0"/>
+              <a:rPr lang="en-US"/>
               <a:t>Second level</a:t>
             </a:r>
           </a:p>
           <a:p>
             <a:pPr lvl="2"/>
             <a:r>
-              <a:rPr lang="en-US" smtClean="0"/>
+              <a:rPr lang="en-US"/>
               <a:t>Third level</a:t>
             </a:r>
           </a:p>
           <a:p>
             <a:pPr lvl="3"/>
             <a:r>
-              <a:rPr lang="en-US" smtClean="0"/>
+              <a:rPr lang="en-US"/>
               <a:t>Fourth level</a:t>
             </a:r>
           </a:p>
           <a:p>
             <a:pPr lvl="4"/>
             <a:r>
-              <a:rPr lang="en-US" smtClean="0"/>
+              <a:rPr lang="en-US"/>
               <a:t>Fifth level</a:t>
             </a:r>
-            <a:endParaRPr lang="en-US"/>
           </a:p>
         </p:txBody>
       </p:sp>
@@ -2727,7 +2751,7 @@
           <a:p>
             <a:fld id="{5BCAD085-E8A6-8845-BD4E-CB4CCA059FC4}" type="datetimeFigureOut">
               <a:rPr lang="en-US" smtClean="0"/>
-              <a:t>1/27/13</a:t>
+              <a:t>5/25/2026</a:t>
             </a:fld>
             <a:endParaRPr lang="en-US"/>
           </a:p>
@@ -3086,7 +3110,7 @@
 </file>
 
 <file path=ppt/slides/slide1.xml><?xml version="1.0" encoding="utf-8"?>
-<p:sld xmlns:a="http://schemas.openxmlformats.org/drawingml/2006/main" xmlns:p="http://schemas.openxmlformats.org/presentationml/2006/main" xmlns:r="http://schemas.openxmlformats.org/officeDocument/2006/relationships">
+<p:sld xmlns:a="http://schemas.openxmlformats.org/drawingml/2006/main" xmlns:r="http://schemas.openxmlformats.org/officeDocument/2006/relationships" xmlns:p="http://schemas.openxmlformats.org/presentationml/2006/main">
   <p:cSld>
     <p:spTree>
       <p:nvGrpSpPr>
@@ -3094,7 +3118,14 @@
         <p:cNvGrpSpPr/>
         <p:nvPr/>
       </p:nvGrpSpPr>
-      <p:grpSpPr/>
+      <p:grpSpPr>
+        <a:xfrm>
+          <a:off x="0" y="0"/>
+          <a:ext cx="0" cy="0"/>
+          <a:chOff x="0" y="0"/>
+          <a:chExt cx="0" cy="0"/>
+        </a:xfrm>
+      </p:grpSpPr>
       <p:sp>
         <p:nvSpPr>
           <p:cNvPr id="2" name="Title 1"/>
@@ -3146,7 +3177,7 @@
 </file>
 
 <file path=ppt/slides/slide2.xml><?xml version="1.0" encoding="utf-8"?>
-<p:sld xmlns:a="http://schemas.openxmlformats.org/drawingml/2006/main" xmlns:p="http://schemas.openxmlformats.org/presentationml/2006/main" xmlns:r="http://schemas.openxmlformats.org/officeDocument/2006/relationships">
+<p:sld xmlns:a="http://schemas.openxmlformats.org/drawingml/2006/main" xmlns:r="http://schemas.openxmlformats.org/officeDocument/2006/relationships" xmlns:p="http://schemas.openxmlformats.org/presentationml/2006/main">
   <p:cSld>
     <p:spTree>
       <p:nvGrpSpPr>
@@ -3154,7 +3185,14 @@
         <p:cNvGrpSpPr/>
         <p:nvPr/>
       </p:nvGrpSpPr>
-      <p:grpSpPr/>
+      <p:grpSpPr>
+        <a:xfrm>
+          <a:off x="0" y="0"/>
+          <a:ext cx="0" cy="0"/>
+          <a:chOff x="0" y="0"/>
+          <a:chExt cx="0" cy="0"/>
+        </a:xfrm>
+      </p:grpSpPr>
       <p:sp>
         <p:nvSpPr>
           <p:cNvPr id="2" name="Title 1"/>
@@ -3202,6 +3240,7 @@
             <a:pPr>
               <a:defRPr sz="1800"/>
             </a:pPr>
+            <a:endParaRPr/>
           </a:p>
           <a:p>
             <a:pPr>
@@ -3246,7 +3285,7 @@
 </file>
 
 <file path=ppt/slides/slide3.xml><?xml version="1.0" encoding="utf-8"?>
-<p:sld xmlns:a="http://schemas.openxmlformats.org/drawingml/2006/main" xmlns:p="http://schemas.openxmlformats.org/presentationml/2006/main" xmlns:r="http://schemas.openxmlformats.org/officeDocument/2006/relationships">
+<p:sld xmlns:a="http://schemas.openxmlformats.org/drawingml/2006/main" xmlns:r="http://schemas.openxmlformats.org/officeDocument/2006/relationships" xmlns:p="http://schemas.openxmlformats.org/presentationml/2006/main">
   <p:cSld>
     <p:spTree>
       <p:nvGrpSpPr>
@@ -3254,7 +3293,14 @@
         <p:cNvGrpSpPr/>
         <p:nvPr/>
       </p:nvGrpSpPr>
-      <p:grpSpPr/>
+      <p:grpSpPr>
+        <a:xfrm>
+          <a:off x="0" y="0"/>
+          <a:ext cx="0" cy="0"/>
+          <a:chOff x="0" y="0"/>
+          <a:chExt cx="0" cy="0"/>
+        </a:xfrm>
+      </p:grpSpPr>
       <p:sp>
         <p:nvSpPr>
           <p:cNvPr id="2" name="Title 1"/>
@@ -3341,7 +3387,7 @@
 </file>
 
 <file path=ppt/slides/slide4.xml><?xml version="1.0" encoding="utf-8"?>
-<p:sld xmlns:a="http://schemas.openxmlformats.org/drawingml/2006/main" xmlns:p="http://schemas.openxmlformats.org/presentationml/2006/main" xmlns:r="http://schemas.openxmlformats.org/officeDocument/2006/relationships">
+<p:sld xmlns:a="http://schemas.openxmlformats.org/drawingml/2006/main" xmlns:r="http://schemas.openxmlformats.org/officeDocument/2006/relationships" xmlns:p="http://schemas.openxmlformats.org/presentationml/2006/main">
   <p:cSld>
     <p:spTree>
       <p:nvGrpSpPr>
@@ -3349,7 +3395,14 @@
         <p:cNvGrpSpPr/>
         <p:nvPr/>
       </p:nvGrpSpPr>
-      <p:grpSpPr/>
+      <p:grpSpPr>
+        <a:xfrm>
+          <a:off x="0" y="0"/>
+          <a:ext cx="0" cy="0"/>
+          <a:chOff x="0" y="0"/>
+          <a:chExt cx="0" cy="0"/>
+        </a:xfrm>
+      </p:grpSpPr>
       <p:sp>
         <p:nvSpPr>
           <p:cNvPr id="2" name="Title 1"/>
@@ -3428,7 +3481,7 @@
 </file>
 
 <file path=ppt/slides/slide5.xml><?xml version="1.0" encoding="utf-8"?>
-<p:sld xmlns:a="http://schemas.openxmlformats.org/drawingml/2006/main" xmlns:p="http://schemas.openxmlformats.org/presentationml/2006/main" xmlns:r="http://schemas.openxmlformats.org/officeDocument/2006/relationships">
+<p:sld xmlns:a="http://schemas.openxmlformats.org/drawingml/2006/main" xmlns:r="http://schemas.openxmlformats.org/officeDocument/2006/relationships" xmlns:p="http://schemas.openxmlformats.org/presentationml/2006/main">
   <p:cSld>
     <p:spTree>
       <p:nvGrpSpPr>
@@ -3436,7 +3489,14 @@
         <p:cNvGrpSpPr/>
         <p:nvPr/>
       </p:nvGrpSpPr>
-      <p:grpSpPr/>
+      <p:grpSpPr>
+        <a:xfrm>
+          <a:off x="0" y="0"/>
+          <a:ext cx="0" cy="0"/>
+          <a:chOff x="0" y="0"/>
+          <a:chExt cx="0" cy="0"/>
+        </a:xfrm>
+      </p:grpSpPr>
       <p:sp>
         <p:nvSpPr>
           <p:cNvPr id="2" name="Title 1"/>
@@ -3515,7 +3575,7 @@
 </file>
 
 <file path=ppt/slides/slide6.xml><?xml version="1.0" encoding="utf-8"?>
-<p:sld xmlns:a="http://schemas.openxmlformats.org/drawingml/2006/main" xmlns:p="http://schemas.openxmlformats.org/presentationml/2006/main" xmlns:r="http://schemas.openxmlformats.org/officeDocument/2006/relationships">
+<p:sld xmlns:a="http://schemas.openxmlformats.org/drawingml/2006/main" xmlns:r="http://schemas.openxmlformats.org/officeDocument/2006/relationships" xmlns:p="http://schemas.openxmlformats.org/presentationml/2006/main">
   <p:cSld>
     <p:spTree>
       <p:nvGrpSpPr>
@@ -3523,165 +3583,14 @@
         <p:cNvGrpSpPr/>
         <p:nvPr/>
       </p:nvGrpSpPr>
-      <p:grpSpPr/>
-      <p:sp>
-        <p:nvSpPr>
-          <p:cNvPr id="2" name="Title 1"/>
-          <p:cNvSpPr>
-            <a:spLocks noGrp="1"/>
-          </p:cNvSpPr>
-          <p:nvPr>
-            <p:ph type="title"/>
-          </p:nvPr>
-        </p:nvSpPr>
-        <p:spPr/>
-        <p:txBody>
-          <a:bodyPr/>
-          <a:lstStyle/>
-          <a:p>
-            <a:r>
-              <a:t>Robustness and limitations</a:t>
-            </a:r>
-          </a:p>
-        </p:txBody>
-      </p:sp>
-      <p:sp>
-        <p:nvSpPr>
-          <p:cNvPr id="3" name="Content Placeholder 2"/>
-          <p:cNvSpPr>
-            <a:spLocks noGrp="1"/>
-          </p:cNvSpPr>
-          <p:nvPr>
-            <p:ph idx="1"/>
-          </p:nvPr>
-        </p:nvSpPr>
-        <p:spPr/>
-        <p:txBody>
-          <a:bodyPr/>
-          <a:lstStyle/>
-          <a:p>
-            <a:pPr>
-              <a:defRPr sz="1800"/>
-            </a:pPr>
-            <a:r>
-              <a:t>Robustness: the association survives unweighted models, no-year models, alternative income transformations, and year-specific samples.</a:t>
-            </a:r>
-          </a:p>
-          <a:p>
-            <a:pPr>
-              <a:defRPr sz="1800"/>
-            </a:pPr>
-            <a:r>
-              <a:t>Limitation: grouped census data lack individual-level controls for age, occupation, hours worked, region, and firm characteristics.</a:t>
-            </a:r>
-          </a:p>
-          <a:p>
-            <a:pPr>
-              <a:defRPr sz="1800"/>
-            </a:pPr>
-            <a:r>
-              <a:t>Largest threat: omitted-variable bias from composition differences across education groups and measurement error from income bracket midpoints.</a:t>
-            </a:r>
-          </a:p>
-        </p:txBody>
-      </p:sp>
-    </p:spTree>
-  </p:cSld>
-  <p:clrMapOvr>
-    <a:masterClrMapping/>
-  </p:clrMapOvr>
-</p:sld>
-</file>
-
-<file path=ppt/slides/slide7.xml><?xml version="1.0" encoding="utf-8"?>
-<p:sld xmlns:a="http://schemas.openxmlformats.org/drawingml/2006/main" xmlns:p="http://schemas.openxmlformats.org/presentationml/2006/main" xmlns:r="http://schemas.openxmlformats.org/officeDocument/2006/relationships">
-  <p:cSld>
-    <p:spTree>
-      <p:nvGrpSpPr>
-        <p:cNvPr id="1" name=""/>
-        <p:cNvGrpSpPr/>
-        <p:nvPr/>
-      </p:nvGrpSpPr>
-      <p:grpSpPr/>
-      <p:sp>
-        <p:nvSpPr>
-          <p:cNvPr id="2" name="Title 1"/>
-          <p:cNvSpPr>
-            <a:spLocks noGrp="1"/>
-          </p:cNvSpPr>
-          <p:nvPr>
-            <p:ph type="title"/>
-          </p:nvPr>
-        </p:nvSpPr>
-        <p:spPr/>
-        <p:txBody>
-          <a:bodyPr/>
-          <a:lstStyle/>
-          <a:p>
-            <a:r>
-              <a:t>Conclusion and next steps</a:t>
-            </a:r>
-          </a:p>
-        </p:txBody>
-      </p:sp>
-      <p:sp>
-        <p:nvSpPr>
-          <p:cNvPr id="3" name="Content Placeholder 2"/>
-          <p:cNvSpPr>
-            <a:spLocks noGrp="1"/>
-          </p:cNvSpPr>
-          <p:nvPr>
-            <p:ph idx="1"/>
-          </p:nvPr>
-        </p:nvSpPr>
-        <p:spPr/>
-        <p:txBody>
-          <a:bodyPr/>
-          <a:lstStyle/>
-          <a:p>
-            <a:pPr>
-              <a:defRPr sz="1800"/>
-            </a:pPr>
-            <a:r>
-              <a:t>Conclusion: there is a strong descriptive education-income gradient for Australian males in 2016 and 2021 census aggregates.</a:t>
-            </a:r>
-          </a:p>
-          <a:p>
-            <a:pPr>
-              <a:defRPr sz="1800"/>
-            </a:pPr>
-            <a:r>
-              <a:t>What we cannot conclude: a causal return to education from this grouped data.</a:t>
-            </a:r>
-          </a:p>
-          <a:p>
-            <a:pPr>
-              <a:defRPr sz="1800"/>
-            </a:pPr>
-            <a:r>
-              <a:t>Next step: use individual-level microdata with controls, or seek quasi-experimental variation or longitudinal data to address the main threat.</a:t>
-            </a:r>
-          </a:p>
-        </p:txBody>
-      </p:sp>
-    </p:spTree>
-  </p:cSld>
-  <p:clrMapOvr>
-    <a:masterClrMapping/>
-  </p:clrMapOvr>
-</p:sld>
-</file>
-
-<file path=ppt/slides/slide8.xml><?xml version="1.0" encoding="utf-8"?>
-<p:sld xmlns:a="http://schemas.openxmlformats.org/drawingml/2006/main" xmlns:p="http://schemas.openxmlformats.org/presentationml/2006/main" xmlns:r="http://schemas.openxmlformats.org/officeDocument/2006/relationships">
-  <p:cSld>
-    <p:spTree>
-      <p:nvGrpSpPr>
-        <p:cNvPr id="1" name=""/>
-        <p:cNvGrpSpPr/>
-        <p:nvPr/>
-      </p:nvGrpSpPr>
-      <p:grpSpPr/>
+      <p:grpSpPr>
+        <a:xfrm>
+          <a:off x="0" y="0"/>
+          <a:ext cx="0" cy="0"/>
+          <a:chOff x="0" y="0"/>
+          <a:chExt cx="0" cy="0"/>
+        </a:xfrm>
+      </p:grpSpPr>
       <p:sp>
         <p:nvSpPr>
           <p:cNvPr id="2" name="Title 1"/>
@@ -3750,7 +3659,7 @@
         </p:blipFill>
         <p:spPr>
           <a:xfrm>
-            <a:off x="457200" y="2926080"/>
+            <a:off x="457200" y="1709928"/>
             <a:ext cx="8229600" cy="4800600"/>
           </a:xfrm>
           <a:prstGeom prst="rect">
@@ -3758,6 +3667,178 @@
           </a:prstGeom>
         </p:spPr>
       </p:pic>
+    </p:spTree>
+  </p:cSld>
+  <p:clrMapOvr>
+    <a:masterClrMapping/>
+  </p:clrMapOvr>
+</p:sld>
+</file>
+
+<file path=ppt/slides/slide7.xml><?xml version="1.0" encoding="utf-8"?>
+<p:sld xmlns:a="http://schemas.openxmlformats.org/drawingml/2006/main" xmlns:r="http://schemas.openxmlformats.org/officeDocument/2006/relationships" xmlns:p="http://schemas.openxmlformats.org/presentationml/2006/main">
+  <p:cSld>
+    <p:spTree>
+      <p:nvGrpSpPr>
+        <p:cNvPr id="1" name=""/>
+        <p:cNvGrpSpPr/>
+        <p:nvPr/>
+      </p:nvGrpSpPr>
+      <p:grpSpPr>
+        <a:xfrm>
+          <a:off x="0" y="0"/>
+          <a:ext cx="0" cy="0"/>
+          <a:chOff x="0" y="0"/>
+          <a:chExt cx="0" cy="0"/>
+        </a:xfrm>
+      </p:grpSpPr>
+      <p:sp>
+        <p:nvSpPr>
+          <p:cNvPr id="2" name="Title 1"/>
+          <p:cNvSpPr>
+            <a:spLocks noGrp="1"/>
+          </p:cNvSpPr>
+          <p:nvPr>
+            <p:ph type="title"/>
+          </p:nvPr>
+        </p:nvSpPr>
+        <p:spPr/>
+        <p:txBody>
+          <a:bodyPr/>
+          <a:lstStyle/>
+          <a:p>
+            <a:r>
+              <a:t>Robustness and limitations</a:t>
+            </a:r>
+          </a:p>
+        </p:txBody>
+      </p:sp>
+      <p:sp>
+        <p:nvSpPr>
+          <p:cNvPr id="3" name="Content Placeholder 2"/>
+          <p:cNvSpPr>
+            <a:spLocks noGrp="1"/>
+          </p:cNvSpPr>
+          <p:nvPr>
+            <p:ph idx="1"/>
+          </p:nvPr>
+        </p:nvSpPr>
+        <p:spPr/>
+        <p:txBody>
+          <a:bodyPr/>
+          <a:lstStyle/>
+          <a:p>
+            <a:pPr>
+              <a:defRPr sz="1800"/>
+            </a:pPr>
+            <a:r>
+              <a:t>Robustness: the association survives unweighted models, no-year models, alternative income transformations, and year-specific samples.</a:t>
+            </a:r>
+          </a:p>
+          <a:p>
+            <a:pPr>
+              <a:defRPr sz="1800"/>
+            </a:pPr>
+            <a:r>
+              <a:t>Limitation: grouped census data lack individual-level controls for age, occupation, hours worked, region, and firm characteristics.</a:t>
+            </a:r>
+          </a:p>
+          <a:p>
+            <a:pPr>
+              <a:defRPr sz="1800"/>
+            </a:pPr>
+            <a:r>
+              <a:t>Largest threat: omitted-variable bias from composition differences across education groups and measurement error from income bracket midpoints.</a:t>
+            </a:r>
+          </a:p>
+        </p:txBody>
+      </p:sp>
+    </p:spTree>
+  </p:cSld>
+  <p:clrMapOvr>
+    <a:masterClrMapping/>
+  </p:clrMapOvr>
+</p:sld>
+</file>
+
+<file path=ppt/slides/slide8.xml><?xml version="1.0" encoding="utf-8"?>
+<p:sld xmlns:a="http://schemas.openxmlformats.org/drawingml/2006/main" xmlns:r="http://schemas.openxmlformats.org/officeDocument/2006/relationships" xmlns:p="http://schemas.openxmlformats.org/presentationml/2006/main">
+  <p:cSld>
+    <p:spTree>
+      <p:nvGrpSpPr>
+        <p:cNvPr id="1" name=""/>
+        <p:cNvGrpSpPr/>
+        <p:nvPr/>
+      </p:nvGrpSpPr>
+      <p:grpSpPr>
+        <a:xfrm>
+          <a:off x="0" y="0"/>
+          <a:ext cx="0" cy="0"/>
+          <a:chOff x="0" y="0"/>
+          <a:chExt cx="0" cy="0"/>
+        </a:xfrm>
+      </p:grpSpPr>
+      <p:sp>
+        <p:nvSpPr>
+          <p:cNvPr id="2" name="Title 1"/>
+          <p:cNvSpPr>
+            <a:spLocks noGrp="1"/>
+          </p:cNvSpPr>
+          <p:nvPr>
+            <p:ph type="title"/>
+          </p:nvPr>
+        </p:nvSpPr>
+        <p:spPr/>
+        <p:txBody>
+          <a:bodyPr/>
+          <a:lstStyle/>
+          <a:p>
+            <a:r>
+              <a:t>Conclusion and next steps</a:t>
+            </a:r>
+          </a:p>
+        </p:txBody>
+      </p:sp>
+      <p:sp>
+        <p:nvSpPr>
+          <p:cNvPr id="3" name="Content Placeholder 2"/>
+          <p:cNvSpPr>
+            <a:spLocks noGrp="1"/>
+          </p:cNvSpPr>
+          <p:nvPr>
+            <p:ph idx="1"/>
+          </p:nvPr>
+        </p:nvSpPr>
+        <p:spPr/>
+        <p:txBody>
+          <a:bodyPr/>
+          <a:lstStyle/>
+          <a:p>
+            <a:pPr>
+              <a:defRPr sz="1800"/>
+            </a:pPr>
+            <a:r>
+              <a:t>Conclusion: there is a strong descriptive education-income gradient for Australian males in 2016 and 2021 census aggregates.</a:t>
+            </a:r>
+          </a:p>
+          <a:p>
+            <a:pPr>
+              <a:defRPr sz="1800"/>
+            </a:pPr>
+            <a:r>
+              <a:t>What we cannot conclude: a causal return to education from this grouped data.</a:t>
+            </a:r>
+          </a:p>
+          <a:p>
+            <a:pPr>
+              <a:defRPr sz="1800"/>
+            </a:pPr>
+            <a:r>
+              <a:t>Next step: use individual-level microdata with controls, or seek quasi-experimental variation or longitudinal data to address the main threat.</a:t>
+            </a:r>
+          </a:p>
+        </p:txBody>
+      </p:sp>
     </p:spTree>
   </p:cSld>
   <p:clrMapOvr>

</xml_diff>